<commit_message>
test(e2e): wave-5 cross-binding specs and generated fixtures
Framework-neutral specs (each compares its project against the React
reference) for the wave-5 limitation closures: 3D chart click-to-select
and drag-to-value (bar3D / surface3D / pie3D), chart userShapes groups,
filtered series, graphic-frame accessibility fields, pixelate animation
filter, after-effects, box / cube transition parity, reflection content,
text-warp envelope parity, off-axis 3D shape camera, compound 3D shapes,
ink tilt live preview and the modify-password prompt.

Fixtures are generated in `global-setup.ts` (pie3D, chart userShape
group, box/cube transition, text-warp fidelity, pixelate filter,
reflection content) and the shape-3d fixture script now carries a
direct `a:fillOverlay` blend so `mix-blend-mode` is covered end to end.

Co-Authored-By: Claude Code <noreply@anthropic.com>
</commit_message>
<xml_diff>
--- a/e2e/fixtures/shape-3d-compound.pptx
+++ b/e2e/fixtures/shape-3d-compound.pptx
@@ -362,7 +362,7 @@
           <a:spcPct val="20000"/>
         </a:spcBef>
         <a:buFont typeface="Arial" panose="020B0604020202020204" pitchFamily="34" charset="0"/>
-        <a:buChar char="&amp;#x2022;"/>
+        <a:buChar char="•"/>
         <a:defRPr sz="3200" kern="1200">
           <a:solidFill>
             <a:schemeClr val="tx1"/>
@@ -563,6 +563,131 @@
               <a:t>Another item</a:t>
             </a:r>
           </a:p>
+        </p:txBody>
+      </p:sp>
+      <p:sp>
+        <p:nvSpPr>
+          <p:cNvPr id="7" name="Blend Overlay"/>
+          <p:cNvSpPr/>
+          <p:nvPr/>
+        </p:nvSpPr>
+        <p:spPr>
+          <a:xfrm>
+            <a:off x="5715000" y="3429000"/>
+            <a:ext cx="2095500" cy="1143000"/>
+          </a:xfrm>
+          <a:prstGeom prst="rect">
+            <a:avLst/>
+          </a:prstGeom>
+          <a:solidFill>
+            <a:srgbClr val="3366CC"/>
+          </a:solidFill>
+          <a:effectLst>
+            <a:fillOverlay blend="mult">
+              <a:solidFill>
+                <a:srgbClr val="FFCC00"/>
+              </a:solidFill>
+            </a:fillOverlay>
+          </a:effectLst>
+        </p:spPr>
+        <p:txBody>
+          <a:bodyPr/>
+          <a:lstStyle/>
+          <a:p/>
+        </p:txBody>
+      </p:sp>
+      <p:sp>
+        <p:nvSpPr>
+          <p:cNvPr id="8" name="Heroic Left Facing"/>
+          <p:cNvSpPr/>
+          <p:nvPr/>
+        </p:nvSpPr>
+        <p:spPr>
+          <a:xfrm>
+            <a:off x="571500" y="4476750"/>
+            <a:ext cx="2095500" cy="1333500"/>
+          </a:xfrm>
+          <a:prstGeom prst="rect">
+            <a:avLst/>
+          </a:prstGeom>
+          <a:solidFill>
+            <a:srgbClr val="3366CC"/>
+          </a:solidFill>
+          <a:scene3d>
+            <a:camera prst="perspectiveHeroicLeftFacing"/>
+            <a:lightRig rig="threePt" dir="t"/>
+          </a:scene3d>
+          <a:sp3d extrusionH="457200">
+            <a:extrusionClr>
+              <a:srgbClr val="112255"/>
+            </a:extrusionClr>
+          </a:sp3d>
+        </p:spPr>
+        <p:txBody>
+          <a:bodyPr/>
+          <a:lstStyle/>
+          <a:p/>
+        </p:txBody>
+      </p:sp>
+      <p:sp>
+        <p:nvSpPr>
+          <p:cNvPr id="9" name="Contrasting Left Facing"/>
+          <p:cNvSpPr/>
+          <p:nvPr/>
+        </p:nvSpPr>
+        <p:spPr>
+          <a:xfrm>
+            <a:off x="3048000" y="4476750"/>
+            <a:ext cx="2095500" cy="1333500"/>
+          </a:xfrm>
+          <a:prstGeom prst="rect">
+            <a:avLst/>
+          </a:prstGeom>
+          <a:solidFill>
+            <a:srgbClr val="3366CC"/>
+          </a:solidFill>
+          <a:scene3d>
+            <a:camera prst="perspectiveContrastingLeftFacing"/>
+            <a:lightRig rig="threePt" dir="t"/>
+          </a:scene3d>
+        </p:spPr>
+        <p:txBody>
+          <a:bodyPr/>
+          <a:lstStyle/>
+          <a:p/>
+        </p:txBody>
+      </p:sp>
+      <p:sp>
+        <p:nvSpPr>
+          <p:cNvPr id="10" name="Oblique Bottom Right"/>
+          <p:cNvSpPr/>
+          <p:nvPr/>
+        </p:nvSpPr>
+        <p:spPr>
+          <a:xfrm>
+            <a:off x="5715000" y="4667250"/>
+            <a:ext cx="2095500" cy="1333500"/>
+          </a:xfrm>
+          <a:prstGeom prst="rect">
+            <a:avLst/>
+          </a:prstGeom>
+          <a:solidFill>
+            <a:srgbClr val="3366CC"/>
+          </a:solidFill>
+          <a:scene3d>
+            <a:camera prst="obliqueBottomRight"/>
+            <a:lightRig rig="threePt" dir="t"/>
+          </a:scene3d>
+          <a:sp3d extrusionH="457200">
+            <a:extrusionClr>
+              <a:srgbClr val="112255"/>
+            </a:extrusionClr>
+          </a:sp3d>
+        </p:spPr>
+        <p:txBody>
+          <a:bodyPr/>
+          <a:lstStyle/>
+          <a:p/>
         </p:txBody>
       </p:sp>
     </p:spTree>

</xml_diff>